<commit_message>
Add Grandchild ASSIGN model and related documentation
- Introduced `sports/541_grandchild_homophily_assign.py` for the Grandchild one-shot ASSIGN method, incorporating endogenous centroids and Quayle-style exponential homophily.
- Added scripts for conducting a rho sweep on empirical 2015 MBB abilities, generating outputs including summary statistics and visualizations.
- Created new documentation files detailing the Grandchild ASSIGN method and its implementation, enhancing clarity and accessibility for users.
- Included various output files such as CSVs and images for analysis and diagnostics related to the Grandchild model.

These changes establish a comprehensive framework for the Grandchild ASSIGN model, facilitating further research and application in the project.
</commit_message>
<xml_diff>
--- a/3-Master_Plan/VECTOR_work/VECTOR_ASSIGN_Dynamic_to_OneShot_Model.pptx
+++ b/3-Master_Plan/VECTOR_work/VECTOR_ASSIGN_Dynamic_to_OneShot_Model.pptx
@@ -7,6 +7,7 @@
   <p:sldIdLst>
     <p:sldId id="256" r:id="rId2"/>
     <p:sldId id="257" r:id="rId3"/>
+    <p:sldId id="259" r:id="rId4"/>
   </p:sldIdLst>
   <p:sldSz cx="12192000" cy="6858000"/>
   <p:notesSz cx="6858000" cy="9144000"/>
@@ -5183,15 +5184,12 @@
               </a:defRPr>
             </a:pPr>
             <a:r>
-              <a:rPr lang="en-US"/>
+              <a:rPr lang="en-US" dirty="0"/>
               <a:t>Child Model</a:t>
             </a:r>
             <a:r>
-              <a:t>: </a:t>
-            </a:r>
-            <a:r>
               <a:rPr dirty="0"/>
-              <a:t>One-Shot Homophilic Initial-League Generator</a:t>
+              <a:t>: One-Shot Homophilic Initial-League Generator</a:t>
             </a:r>
           </a:p>
         </p:txBody>
@@ -7299,6 +7297,1474 @@
 </p:sld>
 </file>
 
+<file path=ppt/slides/slide3.xml><?xml version="1.0" encoding="utf-8"?>
+<p:sld xmlns:a="http://schemas.openxmlformats.org/drawingml/2006/main" xmlns:r="http://schemas.openxmlformats.org/officeDocument/2006/relationships" xmlns:p="http://schemas.openxmlformats.org/presentationml/2006/main">
+  <p:cSld>
+    <p:spTree>
+      <p:nvGrpSpPr>
+        <p:cNvPr id="1" name="">
+          <a:extLst>
+            <a:ext uri="{FF2B5EF4-FFF2-40B4-BE49-F238E27FC236}">
+              <a16:creationId xmlns:a16="http://schemas.microsoft.com/office/drawing/2014/main" id="{915F4F23-B3E1-B313-AA6A-F7EAC78102A9}"/>
+            </a:ext>
+          </a:extLst>
+        </p:cNvPr>
+        <p:cNvGrpSpPr/>
+        <p:nvPr/>
+      </p:nvGrpSpPr>
+      <p:grpSpPr>
+        <a:xfrm>
+          <a:off x="0" y="0"/>
+          <a:ext cx="0" cy="0"/>
+          <a:chOff x="0" y="0"/>
+          <a:chExt cx="0" cy="0"/>
+        </a:xfrm>
+      </p:grpSpPr>
+      <p:sp>
+        <p:nvSpPr>
+          <p:cNvPr id="2" name="TextBox 1">
+            <a:extLst>
+              <a:ext uri="{FF2B5EF4-FFF2-40B4-BE49-F238E27FC236}">
+                <a16:creationId xmlns:a16="http://schemas.microsoft.com/office/drawing/2014/main" id="{91B2F6C1-B44B-6920-B12F-1A2771F88D5E}"/>
+              </a:ext>
+            </a:extLst>
+          </p:cNvPr>
+          <p:cNvSpPr txBox="1"/>
+          <p:nvPr/>
+        </p:nvSpPr>
+        <p:spPr>
+          <a:xfrm>
+            <a:off x="566928" y="228600"/>
+            <a:ext cx="11064240" cy="502920"/>
+          </a:xfrm>
+          <a:prstGeom prst="rect">
+            <a:avLst/>
+          </a:prstGeom>
+          <a:noFill/>
+        </p:spPr>
+        <p:txBody>
+          <a:bodyPr wrap="none">
+            <a:spAutoFit/>
+          </a:bodyPr>
+          <a:lstStyle/>
+          <a:p>
+            <a:pPr>
+              <a:defRPr sz="2500" b="1">
+                <a:solidFill>
+                  <a:srgbClr val="1C3449"/>
+                </a:solidFill>
+              </a:defRPr>
+            </a:pPr>
+            <a:r>
+              <a:t>ASSIGN Grandchild: Endogenous Team Centroids Within One Formation Run</a:t>
+            </a:r>
+          </a:p>
+        </p:txBody>
+      </p:sp>
+      <p:sp>
+        <p:nvSpPr>
+          <p:cNvPr id="3" name="TextBox 2">
+            <a:extLst>
+              <a:ext uri="{FF2B5EF4-FFF2-40B4-BE49-F238E27FC236}">
+                <a16:creationId xmlns:a16="http://schemas.microsoft.com/office/drawing/2014/main" id="{46D5F3F6-CDB8-CF4B-2D14-985E0D6078F9}"/>
+              </a:ext>
+            </a:extLst>
+          </p:cNvPr>
+          <p:cNvSpPr txBox="1"/>
+          <p:nvPr/>
+        </p:nvSpPr>
+        <p:spPr>
+          <a:xfrm>
+            <a:off x="594360" y="749808"/>
+            <a:ext cx="10972800" cy="329184"/>
+          </a:xfrm>
+          <a:prstGeom prst="rect">
+            <a:avLst/>
+          </a:prstGeom>
+          <a:noFill/>
+        </p:spPr>
+        <p:txBody>
+          <a:bodyPr wrap="none">
+            <a:spAutoFit/>
+          </a:bodyPr>
+          <a:lstStyle/>
+          <a:p>
+            <a:pPr>
+              <a:defRPr sz="1300">
+                <a:solidFill>
+                  <a:srgbClr val="2D5B8C"/>
+                </a:solidFill>
+              </a:defRPr>
+            </a:pPr>
+            <a:r>
+              <a:t>Same capacity-constrained homophily rule — but teams begin identical and μⱼ updates after every attachment.</a:t>
+            </a:r>
+          </a:p>
+        </p:txBody>
+      </p:sp>
+      <p:sp>
+        <p:nvSpPr>
+          <p:cNvPr id="4" name="Rounded Rectangle 3">
+            <a:extLst>
+              <a:ext uri="{FF2B5EF4-FFF2-40B4-BE49-F238E27FC236}">
+                <a16:creationId xmlns:a16="http://schemas.microsoft.com/office/drawing/2014/main" id="{B5E64E52-4DF5-419E-6771-50AE5FE4CA29}"/>
+              </a:ext>
+            </a:extLst>
+          </p:cNvPr>
+          <p:cNvSpPr/>
+          <p:nvPr/>
+        </p:nvSpPr>
+        <p:spPr>
+          <a:xfrm>
+            <a:off x="594360" y="1234440"/>
+            <a:ext cx="3337560" cy="1234440"/>
+          </a:xfrm>
+          <a:prstGeom prst="roundRect">
+            <a:avLst/>
+          </a:prstGeom>
+          <a:solidFill>
+            <a:srgbClr val="FFFFFF"/>
+          </a:solidFill>
+          <a:ln w="17780">
+            <a:solidFill>
+              <a:srgbClr val="2D5B8C"/>
+            </a:solidFill>
+          </a:ln>
+        </p:spPr>
+        <p:style>
+          <a:lnRef idx="1">
+            <a:schemeClr val="accent1"/>
+          </a:lnRef>
+          <a:fillRef idx="3">
+            <a:schemeClr val="accent1"/>
+          </a:fillRef>
+          <a:effectRef idx="2">
+            <a:schemeClr val="accent1"/>
+          </a:effectRef>
+          <a:fontRef idx="minor">
+            <a:schemeClr val="lt1"/>
+          </a:fontRef>
+        </p:style>
+        <p:txBody>
+          <a:bodyPr lIns="128016" tIns="91440" rIns="128016" rtlCol="0" anchor="ctr"/>
+          <a:lstStyle/>
+          <a:p>
+            <a:pPr algn="ctr">
+              <a:defRPr sz="1600" b="1">
+                <a:solidFill>
+                  <a:srgbClr val="2D5B8C"/>
+                </a:solidFill>
+              </a:defRPr>
+            </a:pPr>
+            <a:r>
+              <a:t>1  Identical initial teams</a:t>
+            </a:r>
+          </a:p>
+          <a:p>
+            <a:pPr>
+              <a:spcBef>
+                <a:spcPts val="500"/>
+              </a:spcBef>
+              <a:defRPr sz="1250">
+                <a:solidFill>
+                  <a:srgbClr val="202020"/>
+                </a:solidFill>
+              </a:defRPr>
+            </a:pPr>
+            <a:r>
+              <a:t>μⱼ⁽⁰⁾ = μ₀ = Ā   for every j</a:t>
+            </a:r>
+            <a:br/>
+            <a:r>
+              <a:t>Rⱼ⁽⁰⁾ = C   for every j</a:t>
+            </a:r>
+            <a:br/>
+            <a:br/>
+            <a:r>
+              <a:t>No initial between-team differentiation.</a:t>
+            </a:r>
+          </a:p>
+        </p:txBody>
+      </p:sp>
+      <p:sp>
+        <p:nvSpPr>
+          <p:cNvPr id="5" name="Rounded Rectangle 4">
+            <a:extLst>
+              <a:ext uri="{FF2B5EF4-FFF2-40B4-BE49-F238E27FC236}">
+                <a16:creationId xmlns:a16="http://schemas.microsoft.com/office/drawing/2014/main" id="{576C989C-0653-D388-7DD0-B53CD0B682B2}"/>
+              </a:ext>
+            </a:extLst>
+          </p:cNvPr>
+          <p:cNvSpPr/>
+          <p:nvPr/>
+        </p:nvSpPr>
+        <p:spPr>
+          <a:xfrm>
+            <a:off x="4425696" y="1234440"/>
+            <a:ext cx="3337560" cy="1234440"/>
+          </a:xfrm>
+          <a:prstGeom prst="roundRect">
+            <a:avLst/>
+          </a:prstGeom>
+          <a:solidFill>
+            <a:srgbClr val="FFFFFF"/>
+          </a:solidFill>
+          <a:ln w="17780">
+            <a:solidFill>
+              <a:srgbClr val="2D5B8C"/>
+            </a:solidFill>
+          </a:ln>
+        </p:spPr>
+        <p:style>
+          <a:lnRef idx="1">
+            <a:schemeClr val="accent1"/>
+          </a:lnRef>
+          <a:fillRef idx="3">
+            <a:schemeClr val="accent1"/>
+          </a:fillRef>
+          <a:effectRef idx="2">
+            <a:schemeClr val="accent1"/>
+          </a:effectRef>
+          <a:fontRef idx="minor">
+            <a:schemeClr val="lt1"/>
+          </a:fontRef>
+        </p:style>
+        <p:txBody>
+          <a:bodyPr lIns="128016" tIns="91440" rIns="128016" rtlCol="0" anchor="ctr"/>
+          <a:lstStyle/>
+          <a:p>
+            <a:pPr algn="ctr">
+              <a:defRPr sz="1600" b="1">
+                <a:solidFill>
+                  <a:srgbClr val="2D5B8C"/>
+                </a:solidFill>
+              </a:defRPr>
+            </a:pPr>
+            <a:r>
+              <a:t>2  Random player entrance</a:t>
+            </a:r>
+          </a:p>
+          <a:p>
+            <a:pPr>
+              <a:spcBef>
+                <a:spcPts val="500"/>
+              </a:spcBef>
+              <a:defRPr sz="1250">
+                <a:solidFill>
+                  <a:srgbClr val="202020"/>
+                </a:solidFill>
+              </a:defRPr>
+            </a:pPr>
+            <a:r>
+              <a:t>Randomly permute the Aᵢ population.</a:t>
+            </a:r>
+            <a:br/>
+            <a:r>
+              <a:t>s = sequential entrance/assignment event.</a:t>
+            </a:r>
+            <a:br/>
+            <a:br/>
+            <a:r>
+              <a:t>One full queue = one stochastic realization.</a:t>
+            </a:r>
+          </a:p>
+        </p:txBody>
+      </p:sp>
+      <p:sp>
+        <p:nvSpPr>
+          <p:cNvPr id="6" name="Rounded Rectangle 5">
+            <a:extLst>
+              <a:ext uri="{FF2B5EF4-FFF2-40B4-BE49-F238E27FC236}">
+                <a16:creationId xmlns:a16="http://schemas.microsoft.com/office/drawing/2014/main" id="{7D146997-C90D-2538-22CD-D60FBB379D19}"/>
+              </a:ext>
+            </a:extLst>
+          </p:cNvPr>
+          <p:cNvSpPr/>
+          <p:nvPr/>
+        </p:nvSpPr>
+        <p:spPr>
+          <a:xfrm>
+            <a:off x="8257031" y="1234440"/>
+            <a:ext cx="3337560" cy="1234440"/>
+          </a:xfrm>
+          <a:prstGeom prst="roundRect">
+            <a:avLst/>
+          </a:prstGeom>
+          <a:solidFill>
+            <a:srgbClr val="FFFFFF"/>
+          </a:solidFill>
+          <a:ln w="17780">
+            <a:solidFill>
+              <a:srgbClr val="A53737"/>
+            </a:solidFill>
+          </a:ln>
+        </p:spPr>
+        <p:style>
+          <a:lnRef idx="1">
+            <a:schemeClr val="accent1"/>
+          </a:lnRef>
+          <a:fillRef idx="3">
+            <a:schemeClr val="accent1"/>
+          </a:fillRef>
+          <a:effectRef idx="2">
+            <a:schemeClr val="accent1"/>
+          </a:effectRef>
+          <a:fontRef idx="minor">
+            <a:schemeClr val="lt1"/>
+          </a:fontRef>
+        </p:style>
+        <p:txBody>
+          <a:bodyPr lIns="128016" tIns="91440" rIns="128016" rtlCol="0" anchor="ctr"/>
+          <a:lstStyle/>
+          <a:p>
+            <a:pPr algn="ctr">
+              <a:defRPr sz="1600" b="1">
+                <a:solidFill>
+                  <a:srgbClr val="A53737"/>
+                </a:solidFill>
+              </a:defRPr>
+            </a:pPr>
+            <a:r>
+              <a:t>3  Homophilic attachment</a:t>
+            </a:r>
+          </a:p>
+          <a:p>
+            <a:pPr>
+              <a:spcBef>
+                <a:spcPts val="500"/>
+              </a:spcBef>
+              <a:defRPr sz="1250">
+                <a:solidFill>
+                  <a:srgbClr val="202020"/>
+                </a:solidFill>
+              </a:defRPr>
+            </a:pPr>
+            <a:r>
+              <a:t>At each event, open teams compete using remaining capacity × similarity to the team's current centroid.</a:t>
+            </a:r>
+          </a:p>
+        </p:txBody>
+      </p:sp>
+      <mc:AlternateContent xmlns:mc="http://schemas.openxmlformats.org/markup-compatibility/2006">
+        <mc:Choice xmlns:a14="http://schemas.microsoft.com/office/drawing/2010/main" Requires="a14">
+          <p:sp>
+            <p:nvSpPr>
+              <p:cNvPr id="7" name="Rounded Rectangle 6">
+                <a:extLst>
+                  <a:ext uri="{FF2B5EF4-FFF2-40B4-BE49-F238E27FC236}">
+                    <a16:creationId xmlns:a16="http://schemas.microsoft.com/office/drawing/2014/main" id="{966EFFDE-287A-3991-33F0-B17D4DF9E79B}"/>
+                  </a:ext>
+                </a:extLst>
+              </p:cNvPr>
+              <p:cNvSpPr/>
+              <p:nvPr/>
+            </p:nvSpPr>
+            <p:spPr>
+              <a:xfrm>
+                <a:off x="960120" y="2596897"/>
+                <a:ext cx="10268712" cy="1578496"/>
+              </a:xfrm>
+              <a:prstGeom prst="roundRect">
+                <a:avLst/>
+              </a:prstGeom>
+              <a:solidFill>
+                <a:srgbClr val="F4F7F9"/>
+              </a:solidFill>
+              <a:ln>
+                <a:solidFill>
+                  <a:srgbClr val="CDD9E2"/>
+                </a:solidFill>
+              </a:ln>
+            </p:spPr>
+            <p:style>
+              <a:lnRef idx="1">
+                <a:schemeClr val="accent1"/>
+              </a:lnRef>
+              <a:fillRef idx="3">
+                <a:schemeClr val="accent1"/>
+              </a:fillRef>
+              <a:effectRef idx="2">
+                <a:schemeClr val="accent1"/>
+              </a:effectRef>
+              <a:fontRef idx="minor">
+                <a:schemeClr val="lt1"/>
+              </a:fontRef>
+            </p:style>
+            <p:txBody>
+              <a:bodyPr rtlCol="0" anchor="ctr"/>
+              <a:lstStyle/>
+              <a:p>
+                <a:pPr algn="ctr">
+                  <a:defRPr sz="2200" b="1">
+                    <a:solidFill>
+                      <a:srgbClr val="1C3449"/>
+                    </a:solidFill>
+                    <a:latin typeface="Cambria Math"/>
+                  </a:defRPr>
+                </a:pPr>
+                <a14:m>
+                  <m:oMathPara xmlns:m="http://schemas.openxmlformats.org/officeDocument/2006/math">
+                    <m:oMath>
+                      <m:r>
+                        <a:rPr lang="ar-AE" sz="2000" i="1" dirty="0">
+                          <a:solidFill>
+                            <a:prstClr val="black"/>
+                          </a:solidFill>
+                          <a:latin typeface="Cambria Math" panose="02040503050406030204" pitchFamily="18" charset="0"/>
+                        </a:rPr>
+                        <m:t>𝑃</m:t>
+                      </m:r>
+                      <m:r>
+                        <a:rPr lang="ar-AE" sz="2000" i="1" dirty="0">
+                          <a:solidFill>
+                            <a:prstClr val="black"/>
+                          </a:solidFill>
+                          <a:latin typeface="Cambria Math" panose="02040503050406030204" pitchFamily="18" charset="0"/>
+                        </a:rPr>
+                        <m:t>=</m:t>
+                      </m:r>
+                      <m:d>
+                        <m:dPr>
+                          <m:ctrlPr>
+                            <a:rPr lang="ar-AE" sz="2000" i="1" dirty="0">
+                              <a:solidFill>
+                                <a:prstClr val="black"/>
+                              </a:solidFill>
+                              <a:latin typeface="Cambria Math" panose="02040503050406030204" pitchFamily="18" charset="0"/>
+                            </a:rPr>
+                          </m:ctrlPr>
+                        </m:dPr>
+                        <m:e>
+                          <m:r>
+                            <a:rPr lang="ar-AE" sz="2000" i="1" dirty="0">
+                              <a:solidFill>
+                                <a:prstClr val="black"/>
+                              </a:solidFill>
+                              <a:latin typeface="Cambria Math" panose="02040503050406030204" pitchFamily="18" charset="0"/>
+                            </a:rPr>
+                            <m:t>𝑖</m:t>
+                          </m:r>
+                          <m:r>
+                            <a:rPr lang="ar-AE" sz="2000" i="1" dirty="0">
+                              <a:solidFill>
+                                <a:prstClr val="black"/>
+                              </a:solidFill>
+                              <a:latin typeface="Cambria Math" panose="02040503050406030204" pitchFamily="18" charset="0"/>
+                            </a:rPr>
+                            <m:t>→</m:t>
+                          </m:r>
+                          <m:r>
+                            <a:rPr lang="ar-AE" sz="2000" i="1" dirty="0">
+                              <a:solidFill>
+                                <a:prstClr val="black"/>
+                              </a:solidFill>
+                              <a:latin typeface="Cambria Math" panose="02040503050406030204" pitchFamily="18" charset="0"/>
+                            </a:rPr>
+                            <m:t>𝑗</m:t>
+                          </m:r>
+                          <m:r>
+                            <a:rPr lang="ar-AE" sz="2000" i="1" dirty="0">
+                              <a:solidFill>
+                                <a:prstClr val="black"/>
+                              </a:solidFill>
+                              <a:latin typeface="Cambria Math" panose="02040503050406030204" pitchFamily="18" charset="0"/>
+                            </a:rPr>
+                            <m:t> |</m:t>
+                          </m:r>
+                          <m:r>
+                            <m:rPr>
+                              <m:sty m:val="p"/>
+                            </m:rPr>
+                            <a:rPr lang="en-US" sz="2000" i="1" dirty="0">
+                              <a:solidFill>
+                                <a:prstClr val="black"/>
+                              </a:solidFill>
+                              <a:latin typeface="Cambria Math" panose="02040503050406030204" pitchFamily="18" charset="0"/>
+                            </a:rPr>
+                            <m:t>s</m:t>
+                          </m:r>
+                        </m:e>
+                      </m:d>
+                      <m:r>
+                        <a:rPr lang="ar-AE" sz="2000" i="1" dirty="0">
+                          <a:solidFill>
+                            <a:prstClr val="black"/>
+                          </a:solidFill>
+                          <a:latin typeface="Cambria Math" panose="02040503050406030204" pitchFamily="18" charset="0"/>
+                        </a:rPr>
+                        <m:t>=</m:t>
+                      </m:r>
+                      <m:f>
+                        <m:fPr>
+                          <m:ctrlPr>
+                            <a:rPr lang="ar-AE" sz="2000" i="1" dirty="0">
+                              <a:solidFill>
+                                <a:prstClr val="black"/>
+                              </a:solidFill>
+                              <a:latin typeface="Cambria Math" panose="02040503050406030204" pitchFamily="18" charset="0"/>
+                            </a:rPr>
+                          </m:ctrlPr>
+                        </m:fPr>
+                        <m:num>
+                          <m:sSubSup>
+                            <m:sSubSupPr>
+                              <m:ctrlPr>
+                                <a:rPr lang="ar-AE" sz="2000" i="1" dirty="0">
+                                  <a:solidFill>
+                                    <a:prstClr val="black"/>
+                                  </a:solidFill>
+                                  <a:latin typeface="Cambria Math" panose="02040503050406030204" pitchFamily="18" charset="0"/>
+                                </a:rPr>
+                              </m:ctrlPr>
+                            </m:sSubSupPr>
+                            <m:e>
+                              <m:r>
+                                <a:rPr lang="ar-AE" sz="2000" i="1" dirty="0">
+                                  <a:solidFill>
+                                    <a:prstClr val="black"/>
+                                  </a:solidFill>
+                                  <a:latin typeface="Cambria Math" panose="02040503050406030204" pitchFamily="18" charset="0"/>
+                                </a:rPr>
+                                <m:t>𝑅</m:t>
+                              </m:r>
+                            </m:e>
+                            <m:sub>
+                              <m:r>
+                                <a:rPr lang="ar-AE" sz="2000" i="1" dirty="0">
+                                  <a:solidFill>
+                                    <a:prstClr val="black"/>
+                                  </a:solidFill>
+                                  <a:latin typeface="Cambria Math" panose="02040503050406030204" pitchFamily="18" charset="0"/>
+                                </a:rPr>
+                                <m:t>𝑗</m:t>
+                              </m:r>
+                            </m:sub>
+                            <m:sup>
+                              <m:d>
+                                <m:dPr>
+                                  <m:ctrlPr>
+                                    <a:rPr lang="ar-AE" sz="2000" i="1" dirty="0">
+                                      <a:solidFill>
+                                        <a:prstClr val="black"/>
+                                      </a:solidFill>
+                                      <a:latin typeface="Cambria Math" panose="02040503050406030204" pitchFamily="18" charset="0"/>
+                                    </a:rPr>
+                                  </m:ctrlPr>
+                                </m:dPr>
+                                <m:e>
+                                  <m:r>
+                                    <a:rPr lang="ar-AE" sz="2000" i="1" dirty="0">
+                                      <a:solidFill>
+                                        <a:prstClr val="black"/>
+                                      </a:solidFill>
+                                      <a:latin typeface="Cambria Math" panose="02040503050406030204" pitchFamily="18" charset="0"/>
+                                    </a:rPr>
+                                    <m:t>𝑠</m:t>
+                                  </m:r>
+                                </m:e>
+                              </m:d>
+                            </m:sup>
+                          </m:sSubSup>
+                          <m:sSup>
+                            <m:sSupPr>
+                              <m:ctrlPr>
+                                <a:rPr lang="ar-AE" sz="2000" i="1" dirty="0">
+                                  <a:solidFill>
+                                    <a:prstClr val="black"/>
+                                  </a:solidFill>
+                                  <a:latin typeface="Cambria Math" panose="02040503050406030204" pitchFamily="18" charset="0"/>
+                                </a:rPr>
+                              </m:ctrlPr>
+                            </m:sSupPr>
+                            <m:e>
+                              <m:r>
+                                <a:rPr lang="ar-AE" sz="2000" i="1" dirty="0">
+                                  <a:solidFill>
+                                    <a:prstClr val="black"/>
+                                  </a:solidFill>
+                                  <a:latin typeface="Cambria Math" panose="02040503050406030204" pitchFamily="18" charset="0"/>
+                                </a:rPr>
+                                <m:t>𝑒</m:t>
+                              </m:r>
+                            </m:e>
+                            <m:sup>
+                              <m:r>
+                                <a:rPr lang="ar-AE" sz="2000" i="1" dirty="0">
+                                  <a:solidFill>
+                                    <a:prstClr val="black"/>
+                                  </a:solidFill>
+                                  <a:latin typeface="Cambria Math" panose="02040503050406030204" pitchFamily="18" charset="0"/>
+                                </a:rPr>
+                                <m:t>−</m:t>
+                              </m:r>
+                              <m:r>
+                                <a:rPr lang="ar-AE" sz="2000" i="1" dirty="0">
+                                  <a:solidFill>
+                                    <a:prstClr val="black"/>
+                                  </a:solidFill>
+                                  <a:latin typeface="Cambria Math" panose="02040503050406030204" pitchFamily="18" charset="0"/>
+                                </a:rPr>
+                                <m:t>𝜌</m:t>
+                              </m:r>
+                              <m:d>
+                                <m:dPr>
+                                  <m:begChr m:val="|"/>
+                                  <m:endChr m:val="|"/>
+                                  <m:ctrlPr>
+                                    <a:rPr lang="ar-AE" sz="2000" i="1" dirty="0">
+                                      <a:solidFill>
+                                        <a:prstClr val="black"/>
+                                      </a:solidFill>
+                                      <a:latin typeface="Cambria Math" panose="02040503050406030204" pitchFamily="18" charset="0"/>
+                                    </a:rPr>
+                                  </m:ctrlPr>
+                                </m:dPr>
+                                <m:e>
+                                  <m:sSub>
+                                    <m:sSubPr>
+                                      <m:ctrlPr>
+                                        <a:rPr lang="ar-AE" sz="2000" i="1" dirty="0">
+                                          <a:solidFill>
+                                            <a:prstClr val="black"/>
+                                          </a:solidFill>
+                                          <a:latin typeface="Cambria Math" panose="02040503050406030204" pitchFamily="18" charset="0"/>
+                                        </a:rPr>
+                                      </m:ctrlPr>
+                                    </m:sSubPr>
+                                    <m:e>
+                                      <m:r>
+                                        <a:rPr lang="ar-AE" sz="2000" i="1" dirty="0">
+                                          <a:solidFill>
+                                            <a:prstClr val="black"/>
+                                          </a:solidFill>
+                                          <a:latin typeface="Cambria Math" panose="02040503050406030204" pitchFamily="18" charset="0"/>
+                                        </a:rPr>
+                                        <m:t>𝐴</m:t>
+                                      </m:r>
+                                    </m:e>
+                                    <m:sub>
+                                      <m:r>
+                                        <a:rPr lang="ar-AE" sz="2000" i="1" dirty="0">
+                                          <a:solidFill>
+                                            <a:prstClr val="black"/>
+                                          </a:solidFill>
+                                          <a:latin typeface="Cambria Math" panose="02040503050406030204" pitchFamily="18" charset="0"/>
+                                        </a:rPr>
+                                        <m:t>𝑖</m:t>
+                                      </m:r>
+                                    </m:sub>
+                                  </m:sSub>
+                                  <m:r>
+                                    <a:rPr lang="ar-AE" sz="2000" i="1" dirty="0">
+                                      <a:solidFill>
+                                        <a:prstClr val="black"/>
+                                      </a:solidFill>
+                                      <a:latin typeface="Cambria Math" panose="02040503050406030204" pitchFamily="18" charset="0"/>
+                                    </a:rPr>
+                                    <m:t>−</m:t>
+                                  </m:r>
+                                  <m:sSubSup>
+                                    <m:sSubSupPr>
+                                      <m:ctrlPr>
+                                        <a:rPr lang="ar-AE" sz="2000" i="1" dirty="0">
+                                          <a:solidFill>
+                                            <a:prstClr val="black"/>
+                                          </a:solidFill>
+                                          <a:latin typeface="Cambria Math" panose="02040503050406030204" pitchFamily="18" charset="0"/>
+                                        </a:rPr>
+                                      </m:ctrlPr>
+                                    </m:sSubSupPr>
+                                    <m:e>
+                                      <m:r>
+                                        <a:rPr lang="ar-AE" sz="2000" i="1" dirty="0">
+                                          <a:solidFill>
+                                            <a:prstClr val="black"/>
+                                          </a:solidFill>
+                                          <a:latin typeface="Cambria Math" panose="02040503050406030204" pitchFamily="18" charset="0"/>
+                                        </a:rPr>
+                                        <m:t>𝜇</m:t>
+                                      </m:r>
+                                    </m:e>
+                                    <m:sub>
+                                      <m:r>
+                                        <a:rPr lang="ar-AE" sz="2000" i="1" dirty="0">
+                                          <a:solidFill>
+                                            <a:prstClr val="black"/>
+                                          </a:solidFill>
+                                          <a:latin typeface="Cambria Math" panose="02040503050406030204" pitchFamily="18" charset="0"/>
+                                        </a:rPr>
+                                        <m:t>𝑗</m:t>
+                                      </m:r>
+                                    </m:sub>
+                                    <m:sup>
+                                      <m:r>
+                                        <a:rPr lang="en-US" sz="2000" i="1" dirty="0">
+                                          <a:solidFill>
+                                            <a:prstClr val="black"/>
+                                          </a:solidFill>
+                                          <a:latin typeface="Cambria Math" panose="02040503050406030204" pitchFamily="18" charset="0"/>
+                                        </a:rPr>
+                                        <m:t>(</m:t>
+                                      </m:r>
+                                      <m:r>
+                                        <a:rPr lang="en-US" sz="2000" i="1" dirty="0">
+                                          <a:solidFill>
+                                            <a:prstClr val="black"/>
+                                          </a:solidFill>
+                                          <a:latin typeface="Cambria Math" panose="02040503050406030204" pitchFamily="18" charset="0"/>
+                                        </a:rPr>
+                                        <m:t>𝑠</m:t>
+                                      </m:r>
+                                      <m:r>
+                                        <a:rPr lang="en-US" sz="2000" i="1" dirty="0">
+                                          <a:solidFill>
+                                            <a:prstClr val="black"/>
+                                          </a:solidFill>
+                                          <a:latin typeface="Cambria Math" panose="02040503050406030204" pitchFamily="18" charset="0"/>
+                                        </a:rPr>
+                                        <m:t>)</m:t>
+                                      </m:r>
+                                    </m:sup>
+                                  </m:sSubSup>
+                                </m:e>
+                              </m:d>
+                            </m:sup>
+                          </m:sSup>
+                        </m:num>
+                        <m:den>
+                          <m:nary>
+                            <m:naryPr>
+                              <m:chr m:val="∑"/>
+                              <m:limLoc m:val="subSup"/>
+                              <m:supHide m:val="on"/>
+                              <m:ctrlPr>
+                                <a:rPr lang="en-US" sz="2000" i="1" dirty="0">
+                                  <a:solidFill>
+                                    <a:prstClr val="black"/>
+                                  </a:solidFill>
+                                  <a:latin typeface="Cambria Math" panose="02040503050406030204" pitchFamily="18" charset="0"/>
+                                </a:rPr>
+                              </m:ctrlPr>
+                            </m:naryPr>
+                            <m:sub>
+                              <m:r>
+                                <m:rPr>
+                                  <m:sty m:val="p"/>
+                                  <m:brk m:alnAt="9"/>
+                                </m:rPr>
+                                <a:rPr lang="en-US" sz="2000" i="1" dirty="0">
+                                  <a:solidFill>
+                                    <a:prstClr val="black"/>
+                                  </a:solidFill>
+                                  <a:latin typeface="Cambria Math" panose="02040503050406030204" pitchFamily="18" charset="0"/>
+                                </a:rPr>
+                                <m:t>l</m:t>
+                              </m:r>
+                            </m:sub>
+                            <m:sup/>
+                            <m:e>
+                              <m:sSubSup>
+                                <m:sSubSupPr>
+                                  <m:ctrlPr>
+                                    <a:rPr lang="ar-AE" sz="2000" i="1" dirty="0">
+                                      <a:solidFill>
+                                        <a:prstClr val="black"/>
+                                      </a:solidFill>
+                                      <a:latin typeface="Cambria Math" panose="02040503050406030204" pitchFamily="18" charset="0"/>
+                                    </a:rPr>
+                                  </m:ctrlPr>
+                                </m:sSubSupPr>
+                                <m:e>
+                                  <m:r>
+                                    <a:rPr lang="ar-AE" sz="2000" i="1" dirty="0">
+                                      <a:solidFill>
+                                        <a:prstClr val="black"/>
+                                      </a:solidFill>
+                                      <a:latin typeface="Cambria Math" panose="02040503050406030204" pitchFamily="18" charset="0"/>
+                                    </a:rPr>
+                                    <m:t>𝑅</m:t>
+                                  </m:r>
+                                </m:e>
+                                <m:sub>
+                                  <m:r>
+                                    <a:rPr lang="ar-AE" sz="2000" i="1" dirty="0">
+                                      <a:solidFill>
+                                        <a:prstClr val="black"/>
+                                      </a:solidFill>
+                                      <a:latin typeface="Cambria Math" panose="02040503050406030204" pitchFamily="18" charset="0"/>
+                                    </a:rPr>
+                                    <m:t>𝑙</m:t>
+                                  </m:r>
+                                </m:sub>
+                                <m:sup>
+                                  <m:d>
+                                    <m:dPr>
+                                      <m:ctrlPr>
+                                        <a:rPr lang="ar-AE" sz="2000" i="1" dirty="0">
+                                          <a:solidFill>
+                                            <a:prstClr val="black"/>
+                                          </a:solidFill>
+                                          <a:latin typeface="Cambria Math" panose="02040503050406030204" pitchFamily="18" charset="0"/>
+                                        </a:rPr>
+                                      </m:ctrlPr>
+                                    </m:dPr>
+                                    <m:e>
+                                      <m:r>
+                                        <a:rPr lang="ar-AE" sz="2000" i="1" dirty="0">
+                                          <a:solidFill>
+                                            <a:prstClr val="black"/>
+                                          </a:solidFill>
+                                          <a:latin typeface="Cambria Math" panose="02040503050406030204" pitchFamily="18" charset="0"/>
+                                        </a:rPr>
+                                        <m:t>𝑠</m:t>
+                                      </m:r>
+                                    </m:e>
+                                  </m:d>
+                                </m:sup>
+                              </m:sSubSup>
+                              <m:sSup>
+                                <m:sSupPr>
+                                  <m:ctrlPr>
+                                    <a:rPr lang="ar-AE" sz="2000" i="1" dirty="0">
+                                      <a:solidFill>
+                                        <a:prstClr val="black"/>
+                                      </a:solidFill>
+                                      <a:latin typeface="Cambria Math" panose="02040503050406030204" pitchFamily="18" charset="0"/>
+                                    </a:rPr>
+                                  </m:ctrlPr>
+                                </m:sSupPr>
+                                <m:e>
+                                  <m:r>
+                                    <a:rPr lang="ar-AE" sz="2000" i="1" dirty="0">
+                                      <a:solidFill>
+                                        <a:prstClr val="black"/>
+                                      </a:solidFill>
+                                      <a:latin typeface="Cambria Math" panose="02040503050406030204" pitchFamily="18" charset="0"/>
+                                    </a:rPr>
+                                    <m:t>𝑒</m:t>
+                                  </m:r>
+                                </m:e>
+                                <m:sup>
+                                  <m:r>
+                                    <a:rPr lang="ar-AE" sz="2000" i="1" dirty="0">
+                                      <a:solidFill>
+                                        <a:prstClr val="black"/>
+                                      </a:solidFill>
+                                      <a:latin typeface="Cambria Math" panose="02040503050406030204" pitchFamily="18" charset="0"/>
+                                    </a:rPr>
+                                    <m:t>−</m:t>
+                                  </m:r>
+                                  <m:r>
+                                    <a:rPr lang="ar-AE" sz="2000" i="1" dirty="0">
+                                      <a:solidFill>
+                                        <a:prstClr val="black"/>
+                                      </a:solidFill>
+                                      <a:latin typeface="Cambria Math" panose="02040503050406030204" pitchFamily="18" charset="0"/>
+                                    </a:rPr>
+                                    <m:t>𝜌</m:t>
+                                  </m:r>
+                                  <m:d>
+                                    <m:dPr>
+                                      <m:begChr m:val="|"/>
+                                      <m:endChr m:val="|"/>
+                                      <m:ctrlPr>
+                                        <a:rPr lang="ar-AE" sz="2000" i="1" dirty="0">
+                                          <a:solidFill>
+                                            <a:prstClr val="black"/>
+                                          </a:solidFill>
+                                          <a:latin typeface="Cambria Math" panose="02040503050406030204" pitchFamily="18" charset="0"/>
+                                        </a:rPr>
+                                      </m:ctrlPr>
+                                    </m:dPr>
+                                    <m:e>
+                                      <m:sSub>
+                                        <m:sSubPr>
+                                          <m:ctrlPr>
+                                            <a:rPr lang="ar-AE" sz="2000" i="1" dirty="0">
+                                              <a:solidFill>
+                                                <a:prstClr val="black"/>
+                                              </a:solidFill>
+                                              <a:latin typeface="Cambria Math" panose="02040503050406030204" pitchFamily="18" charset="0"/>
+                                            </a:rPr>
+                                          </m:ctrlPr>
+                                        </m:sSubPr>
+                                        <m:e>
+                                          <m:r>
+                                            <a:rPr lang="ar-AE" sz="2000" i="1" dirty="0">
+                                              <a:solidFill>
+                                                <a:prstClr val="black"/>
+                                              </a:solidFill>
+                                              <a:latin typeface="Cambria Math" panose="02040503050406030204" pitchFamily="18" charset="0"/>
+                                            </a:rPr>
+                                            <m:t>𝐴</m:t>
+                                          </m:r>
+                                        </m:e>
+                                        <m:sub>
+                                          <m:r>
+                                            <a:rPr lang="en-US" sz="2000" i="1" dirty="0">
+                                              <a:solidFill>
+                                                <a:prstClr val="black"/>
+                                              </a:solidFill>
+                                              <a:latin typeface="Cambria Math" panose="02040503050406030204" pitchFamily="18" charset="0"/>
+                                            </a:rPr>
+                                            <m:t>𝑖</m:t>
+                                          </m:r>
+                                        </m:sub>
+                                      </m:sSub>
+                                      <m:r>
+                                        <a:rPr lang="ar-AE" sz="2000" i="1" dirty="0">
+                                          <a:solidFill>
+                                            <a:prstClr val="black"/>
+                                          </a:solidFill>
+                                          <a:latin typeface="Cambria Math" panose="02040503050406030204" pitchFamily="18" charset="0"/>
+                                        </a:rPr>
+                                        <m:t>−</m:t>
+                                      </m:r>
+                                      <m:sSubSup>
+                                        <m:sSubSupPr>
+                                          <m:ctrlPr>
+                                            <a:rPr lang="ar-AE" sz="2000" i="1" dirty="0">
+                                              <a:solidFill>
+                                                <a:prstClr val="black"/>
+                                              </a:solidFill>
+                                              <a:latin typeface="Cambria Math" panose="02040503050406030204" pitchFamily="18" charset="0"/>
+                                            </a:rPr>
+                                          </m:ctrlPr>
+                                        </m:sSubSupPr>
+                                        <m:e>
+                                          <m:r>
+                                            <a:rPr lang="ar-AE" sz="2000" i="1" dirty="0">
+                                              <a:solidFill>
+                                                <a:prstClr val="black"/>
+                                              </a:solidFill>
+                                              <a:latin typeface="Cambria Math" panose="02040503050406030204" pitchFamily="18" charset="0"/>
+                                            </a:rPr>
+                                            <m:t>𝜇</m:t>
+                                          </m:r>
+                                        </m:e>
+                                        <m:sub>
+                                          <m:r>
+                                            <a:rPr lang="ar-AE" sz="2000" i="1" dirty="0">
+                                              <a:solidFill>
+                                                <a:prstClr val="black"/>
+                                              </a:solidFill>
+                                              <a:latin typeface="Cambria Math" panose="02040503050406030204" pitchFamily="18" charset="0"/>
+                                            </a:rPr>
+                                            <m:t>𝑙</m:t>
+                                          </m:r>
+                                        </m:sub>
+                                        <m:sup>
+                                          <m:r>
+                                            <a:rPr lang="en-US" sz="2000" i="1" dirty="0">
+                                              <a:solidFill>
+                                                <a:prstClr val="black"/>
+                                              </a:solidFill>
+                                              <a:latin typeface="Cambria Math" panose="02040503050406030204" pitchFamily="18" charset="0"/>
+                                            </a:rPr>
+                                            <m:t>(</m:t>
+                                          </m:r>
+                                          <m:r>
+                                            <a:rPr lang="en-US" sz="2000" i="1" dirty="0">
+                                              <a:solidFill>
+                                                <a:prstClr val="black"/>
+                                              </a:solidFill>
+                                              <a:latin typeface="Cambria Math" panose="02040503050406030204" pitchFamily="18" charset="0"/>
+                                            </a:rPr>
+                                            <m:t>𝑠</m:t>
+                                          </m:r>
+                                          <m:r>
+                                            <a:rPr lang="en-US" sz="2000" i="1" dirty="0">
+                                              <a:solidFill>
+                                                <a:prstClr val="black"/>
+                                              </a:solidFill>
+                                              <a:latin typeface="Cambria Math" panose="02040503050406030204" pitchFamily="18" charset="0"/>
+                                            </a:rPr>
+                                            <m:t>)</m:t>
+                                          </m:r>
+                                        </m:sup>
+                                      </m:sSubSup>
+                                    </m:e>
+                                  </m:d>
+                                </m:sup>
+                              </m:sSup>
+                            </m:e>
+                          </m:nary>
+                          <m:r>
+                            <a:rPr lang="ar-AE" sz="2000" i="1" dirty="0">
+                              <a:solidFill>
+                                <a:prstClr val="black"/>
+                              </a:solidFill>
+                              <a:latin typeface="Cambria Math" panose="02040503050406030204" pitchFamily="18" charset="0"/>
+                            </a:rPr>
+                            <m:t> </m:t>
+                          </m:r>
+                        </m:den>
+                      </m:f>
+                      <m:r>
+                        <a:rPr lang="ar-AE" sz="2000" i="1" dirty="0">
+                          <a:solidFill>
+                            <a:prstClr val="black"/>
+                          </a:solidFill>
+                          <a:latin typeface="Cambria Math" panose="02040503050406030204" pitchFamily="18" charset="0"/>
+                        </a:rPr>
+                        <m:t> </m:t>
+                      </m:r>
+                    </m:oMath>
+                  </m:oMathPara>
+                </a14:m>
+                <a:endParaRPr lang="ar-AE" sz="2800" dirty="0"/>
+              </a:p>
+              <a:p>
+                <a:pPr algn="ctr">
+                  <a:defRPr sz="1100">
+                    <a:solidFill>
+                      <a:srgbClr val="5A646C"/>
+                    </a:solidFill>
+                  </a:defRPr>
+                </a:pPr>
+                <a:r>
+                  <a:rPr lang="el-GR" sz="1400" dirty="0" err="1"/>
+                  <a:t>ρ</a:t>
+                </a:r>
+                <a:r>
+                  <a:rPr lang="el-GR" sz="1400" dirty="0"/>
+                  <a:t> = </a:t>
+                </a:r>
+                <a:r>
+                  <a:rPr lang="en-US" sz="1400" dirty="0"/>
+                  <a:t>homophilic preference   •   Rⱼ = remaining team slots   •   </a:t>
+                </a:r>
+                <a:r>
+                  <a:rPr lang="el-GR" sz="1400" dirty="0" err="1"/>
+                  <a:t>μ</a:t>
+                </a:r>
+                <a:r>
+                  <a:rPr lang="en-US" sz="1400" dirty="0"/>
+                  <a:t>ⱼ⁽</a:t>
+                </a:r>
+                <a:r>
+                  <a:rPr lang="en-US" sz="1400" dirty="0" err="1"/>
+                  <a:t>ˢ</a:t>
+                </a:r>
+                <a:r>
+                  <a:rPr lang="en-US" sz="1400" dirty="0"/>
+                  <a:t>⁾ = current team centroid</a:t>
+                </a:r>
+                <a:endParaRPr sz="1400" dirty="0"/>
+              </a:p>
+            </p:txBody>
+          </p:sp>
+        </mc:Choice>
+        <mc:Fallback>
+          <p:sp>
+            <p:nvSpPr>
+              <p:cNvPr id="7" name="Rounded Rectangle 6">
+                <a:extLst>
+                  <a:ext uri="{FF2B5EF4-FFF2-40B4-BE49-F238E27FC236}">
+                    <a16:creationId xmlns:a16="http://schemas.microsoft.com/office/drawing/2014/main" id="{966EFFDE-287A-3991-33F0-B17D4DF9E79B}"/>
+                  </a:ext>
+                </a:extLst>
+              </p:cNvPr>
+              <p:cNvSpPr>
+                <a:spLocks noRot="1" noChangeAspect="1" noMove="1" noResize="1" noEditPoints="1" noAdjustHandles="1" noChangeArrowheads="1" noChangeShapeType="1" noTextEdit="1"/>
+              </p:cNvSpPr>
+              <p:nvPr/>
+            </p:nvSpPr>
+            <p:spPr>
+              <a:xfrm>
+                <a:off x="960120" y="2596897"/>
+                <a:ext cx="10268712" cy="1578496"/>
+              </a:xfrm>
+              <a:prstGeom prst="roundRect">
+                <a:avLst/>
+              </a:prstGeom>
+              <a:blipFill>
+                <a:blip r:embed="rId2"/>
+                <a:stretch>
+                  <a:fillRect/>
+                </a:stretch>
+              </a:blipFill>
+              <a:ln>
+                <a:solidFill>
+                  <a:srgbClr val="CDD9E2"/>
+                </a:solidFill>
+              </a:ln>
+            </p:spPr>
+            <p:txBody>
+              <a:bodyPr/>
+              <a:lstStyle/>
+              <a:p>
+                <a:r>
+                  <a:rPr lang="en-US">
+                    <a:noFill/>
+                  </a:rPr>
+                  <a:t> </a:t>
+                </a:r>
+              </a:p>
+            </p:txBody>
+          </p:sp>
+        </mc:Fallback>
+      </mc:AlternateContent>
+      <p:sp>
+        <p:nvSpPr>
+          <p:cNvPr id="8" name="Rounded Rectangle 7">
+            <a:extLst>
+              <a:ext uri="{FF2B5EF4-FFF2-40B4-BE49-F238E27FC236}">
+                <a16:creationId xmlns:a16="http://schemas.microsoft.com/office/drawing/2014/main" id="{70A13BC4-710E-ED3B-695B-2C8511C5DD2D}"/>
+              </a:ext>
+            </a:extLst>
+          </p:cNvPr>
+          <p:cNvSpPr/>
+          <p:nvPr/>
+        </p:nvSpPr>
+        <p:spPr>
+          <a:xfrm>
+            <a:off x="658368" y="4261104"/>
+            <a:ext cx="3429000" cy="1234440"/>
+          </a:xfrm>
+          <a:prstGeom prst="roundRect">
+            <a:avLst/>
+          </a:prstGeom>
+          <a:solidFill>
+            <a:srgbClr val="FFFFFF"/>
+          </a:solidFill>
+          <a:ln w="17780">
+            <a:solidFill>
+              <a:srgbClr val="2D5B8C"/>
+            </a:solidFill>
+          </a:ln>
+        </p:spPr>
+        <p:style>
+          <a:lnRef idx="1">
+            <a:schemeClr val="accent1"/>
+          </a:lnRef>
+          <a:fillRef idx="3">
+            <a:schemeClr val="accent1"/>
+          </a:fillRef>
+          <a:effectRef idx="2">
+            <a:schemeClr val="accent1"/>
+          </a:effectRef>
+          <a:fontRef idx="minor">
+            <a:schemeClr val="lt1"/>
+          </a:fontRef>
+        </p:style>
+        <p:txBody>
+          <a:bodyPr lIns="128016" tIns="91440" rIns="128016" rtlCol="0" anchor="ctr"/>
+          <a:lstStyle/>
+          <a:p>
+            <a:pPr algn="ctr">
+              <a:defRPr sz="1600" b="1">
+                <a:solidFill>
+                  <a:srgbClr val="2D5B8C"/>
+                </a:solidFill>
+              </a:defRPr>
+            </a:pPr>
+            <a:r>
+              <a:t>4  Attach + consume a slot</a:t>
+            </a:r>
+          </a:p>
+          <a:p>
+            <a:pPr>
+              <a:spcBef>
+                <a:spcPts val="500"/>
+              </a:spcBef>
+              <a:defRPr sz="1250">
+                <a:solidFill>
+                  <a:srgbClr val="202020"/>
+                </a:solidFill>
+              </a:defRPr>
+            </a:pPr>
+            <a:r>
+              <a:t>If player i joins team j:</a:t>
+            </a:r>
+            <a:br/>
+            <a:r>
+              <a:t>Rⱼ⁽ˢ⁺¹⁾ = Rⱼ⁽ˢ⁾ − 1</a:t>
+            </a:r>
+            <a:br/>
+            <a:br/>
+            <a:r>
+              <a:t>A full team automatically leaves the choice set.</a:t>
+            </a:r>
+          </a:p>
+        </p:txBody>
+      </p:sp>
+      <p:sp>
+        <p:nvSpPr>
+          <p:cNvPr id="9" name="Rounded Rectangle 8">
+            <a:extLst>
+              <a:ext uri="{FF2B5EF4-FFF2-40B4-BE49-F238E27FC236}">
+                <a16:creationId xmlns:a16="http://schemas.microsoft.com/office/drawing/2014/main" id="{B25600B8-661E-DA33-E2B5-CC1798370B2F}"/>
+              </a:ext>
+            </a:extLst>
+          </p:cNvPr>
+          <p:cNvSpPr/>
+          <p:nvPr/>
+        </p:nvSpPr>
+        <p:spPr>
+          <a:xfrm>
+            <a:off x="4379976" y="4261104"/>
+            <a:ext cx="3429000" cy="1234440"/>
+          </a:xfrm>
+          <a:prstGeom prst="roundRect">
+            <a:avLst/>
+          </a:prstGeom>
+          <a:solidFill>
+            <a:srgbClr val="FFFFFF"/>
+          </a:solidFill>
+          <a:ln w="17780">
+            <a:solidFill>
+              <a:srgbClr val="A53737"/>
+            </a:solidFill>
+          </a:ln>
+        </p:spPr>
+        <p:style>
+          <a:lnRef idx="1">
+            <a:schemeClr val="accent1"/>
+          </a:lnRef>
+          <a:fillRef idx="3">
+            <a:schemeClr val="accent1"/>
+          </a:fillRef>
+          <a:effectRef idx="2">
+            <a:schemeClr val="accent1"/>
+          </a:effectRef>
+          <a:fontRef idx="minor">
+            <a:schemeClr val="lt1"/>
+          </a:fontRef>
+        </p:style>
+        <p:txBody>
+          <a:bodyPr lIns="128016" tIns="91440" rIns="128016" rtlCol="0" anchor="ctr"/>
+          <a:lstStyle/>
+          <a:p>
+            <a:pPr algn="ctr">
+              <a:defRPr sz="1600" b="1">
+                <a:solidFill>
+                  <a:srgbClr val="A53737"/>
+                </a:solidFill>
+              </a:defRPr>
+            </a:pPr>
+            <a:r>
+              <a:t>5  Immediately update μⱼ</a:t>
+            </a:r>
+          </a:p>
+          <a:p>
+            <a:pPr>
+              <a:spcBef>
+                <a:spcPts val="500"/>
+              </a:spcBef>
+              <a:defRPr sz="1250">
+                <a:solidFill>
+                  <a:srgbClr val="202020"/>
+                </a:solidFill>
+              </a:defRPr>
+            </a:pPr>
+            <a:r>
+              <a:t>First member:  μⱼ = Aᵢ</a:t>
+            </a:r>
+            <a:br/>
+            <a:r>
+              <a:t>Thereafter μⱼ is the mean of actual attached players.</a:t>
+            </a:r>
+            <a:br/>
+            <a:r>
+              <a:t>μ₀ is NOT a pseudo-player.</a:t>
+            </a:r>
+          </a:p>
+        </p:txBody>
+      </p:sp>
+      <p:sp>
+        <p:nvSpPr>
+          <p:cNvPr id="10" name="Rounded Rectangle 9">
+            <a:extLst>
+              <a:ext uri="{FF2B5EF4-FFF2-40B4-BE49-F238E27FC236}">
+                <a16:creationId xmlns:a16="http://schemas.microsoft.com/office/drawing/2014/main" id="{EBECF42C-3482-A8AD-513F-488D928057FD}"/>
+              </a:ext>
+            </a:extLst>
+          </p:cNvPr>
+          <p:cNvSpPr/>
+          <p:nvPr/>
+        </p:nvSpPr>
+        <p:spPr>
+          <a:xfrm>
+            <a:off x="8101583" y="4261104"/>
+            <a:ext cx="3429000" cy="1234440"/>
+          </a:xfrm>
+          <a:prstGeom prst="roundRect">
+            <a:avLst/>
+          </a:prstGeom>
+          <a:solidFill>
+            <a:srgbClr val="FFFFFF"/>
+          </a:solidFill>
+          <a:ln w="17780">
+            <a:solidFill>
+              <a:srgbClr val="2D5B8C"/>
+            </a:solidFill>
+          </a:ln>
+        </p:spPr>
+        <p:style>
+          <a:lnRef idx="1">
+            <a:schemeClr val="accent1"/>
+          </a:lnRef>
+          <a:fillRef idx="3">
+            <a:schemeClr val="accent1"/>
+          </a:fillRef>
+          <a:effectRef idx="2">
+            <a:schemeClr val="accent1"/>
+          </a:effectRef>
+          <a:fontRef idx="minor">
+            <a:schemeClr val="lt1"/>
+          </a:fontRef>
+        </p:style>
+        <p:txBody>
+          <a:bodyPr lIns="128016" tIns="91440" rIns="128016" rtlCol="0" anchor="ctr"/>
+          <a:lstStyle/>
+          <a:p>
+            <a:pPr algn="ctr">
+              <a:defRPr sz="1600" b="1">
+                <a:solidFill>
+                  <a:srgbClr val="2D5B8C"/>
+                </a:solidFill>
+              </a:defRPr>
+            </a:pPr>
+            <a:r>
+              <a:t>6  Emergent differentiation</a:t>
+            </a:r>
+          </a:p>
+          <a:p>
+            <a:pPr>
+              <a:spcBef>
+                <a:spcPts val="500"/>
+              </a:spcBef>
+              <a:defRPr sz="1250">
+                <a:solidFill>
+                  <a:srgbClr val="202020"/>
+                </a:solidFill>
+              </a:defRPr>
+            </a:pPr>
+            <a:r>
+              <a:t>Repeat until all C slots are filled.</a:t>
+            </a:r>
+            <a:br/>
+            <a:r>
+              <a:t>Teams began identical; final μⱼ differences emerge from stochastic arrivals + homophily + capacity.</a:t>
+            </a:r>
+          </a:p>
+        </p:txBody>
+      </p:sp>
+      <p:sp>
+        <p:nvSpPr>
+          <p:cNvPr id="11" name="Rounded Rectangle 10">
+            <a:extLst>
+              <a:ext uri="{FF2B5EF4-FFF2-40B4-BE49-F238E27FC236}">
+                <a16:creationId xmlns:a16="http://schemas.microsoft.com/office/drawing/2014/main" id="{F6D9B41F-636F-6FA7-FF71-3926FDD53349}"/>
+              </a:ext>
+            </a:extLst>
+          </p:cNvPr>
+          <p:cNvSpPr/>
+          <p:nvPr/>
+        </p:nvSpPr>
+        <p:spPr>
+          <a:xfrm>
+            <a:off x="1115568" y="5760720"/>
+            <a:ext cx="9966960" cy="502920"/>
+          </a:xfrm>
+          <a:prstGeom prst="roundRect">
+            <a:avLst/>
+          </a:prstGeom>
+          <a:solidFill>
+            <a:srgbClr val="1C3449"/>
+          </a:solidFill>
+          <a:ln>
+            <a:solidFill>
+              <a:srgbClr val="1C3449"/>
+            </a:solidFill>
+          </a:ln>
+        </p:spPr>
+        <p:style>
+          <a:lnRef idx="1">
+            <a:schemeClr val="accent1"/>
+          </a:lnRef>
+          <a:fillRef idx="3">
+            <a:schemeClr val="accent1"/>
+          </a:fillRef>
+          <a:effectRef idx="2">
+            <a:schemeClr val="accent1"/>
+          </a:effectRef>
+          <a:fontRef idx="minor">
+            <a:schemeClr val="lt1"/>
+          </a:fontRef>
+        </p:style>
+        <p:txBody>
+          <a:bodyPr rtlCol="0" anchor="ctr"/>
+          <a:lstStyle/>
+          <a:p>
+            <a:pPr algn="ctr">
+              <a:defRPr sz="1400" b="1">
+                <a:solidFill>
+                  <a:srgbClr val="FFFFFF"/>
+                </a:solidFill>
+              </a:defRPr>
+            </a:pPr>
+            <a:r>
+              <a:t>TEST:  ρ ↑  →  within-team dispersion D ↓ ?   •   normalized sorting H ↑ ?   •   what is the functional shape?</a:t>
+            </a:r>
+          </a:p>
+        </p:txBody>
+      </p:sp>
+      <p:sp>
+        <p:nvSpPr>
+          <p:cNvPr id="12" name="TextBox 11">
+            <a:extLst>
+              <a:ext uri="{FF2B5EF4-FFF2-40B4-BE49-F238E27FC236}">
+                <a16:creationId xmlns:a16="http://schemas.microsoft.com/office/drawing/2014/main" id="{C6CA272F-F5A4-56C3-6038-CB05AB4603FB}"/>
+              </a:ext>
+            </a:extLst>
+          </p:cNvPr>
+          <p:cNvSpPr txBox="1"/>
+          <p:nvPr/>
+        </p:nvSpPr>
+        <p:spPr>
+          <a:xfrm>
+            <a:off x="621792" y="6446520"/>
+            <a:ext cx="10972800" cy="182880"/>
+          </a:xfrm>
+          <a:prstGeom prst="rect">
+            <a:avLst/>
+          </a:prstGeom>
+          <a:noFill/>
+        </p:spPr>
+        <p:txBody>
+          <a:bodyPr wrap="none">
+            <a:spAutoFit/>
+          </a:bodyPr>
+          <a:lstStyle/>
+          <a:p>
+            <a:pPr>
+              <a:defRPr sz="850">
+                <a:solidFill>
+                  <a:srgbClr val="5A646C"/>
+                </a:solidFill>
+              </a:defRPr>
+            </a:pPr>
+            <a:r>
+              <a:t>Grandchild preserves the Parent/Child weighted-stub + Quayle-style homophily logic; only the within-run centroid rule changes.</a:t>
+            </a:r>
+          </a:p>
+        </p:txBody>
+      </p:sp>
+    </p:spTree>
+    <p:extLst>
+      <p:ext uri="{BB962C8B-B14F-4D97-AF65-F5344CB8AC3E}">
+        <p14:creationId xmlns:p14="http://schemas.microsoft.com/office/powerpoint/2010/main" val="4028519266"/>
+      </p:ext>
+    </p:extLst>
+  </p:cSld>
+  <p:clrMapOvr>
+    <a:masterClrMapping/>
+  </p:clrMapOvr>
+</p:sld>
+</file>
+
 <file path=ppt/theme/theme1.xml><?xml version="1.0" encoding="utf-8"?>
 <a:theme xmlns:a="http://schemas.openxmlformats.org/drawingml/2006/main" name="Office Theme">
   <a:themeElements>

</xml_diff>